<commit_message>
Report and Poster Updated
</commit_message>
<xml_diff>
--- a/documents/BİTİRME PROJESİ POSTER TASLAĞI.pptx
+++ b/documents/BİTİRME PROJESİ POSTER TASLAĞI.pptx
@@ -2,34 +2,34 @@
 <file path=ppt/presentation.xml><?xml version="1.0" encoding="utf-8"?>
 <p:presentation xmlns:a="http://schemas.openxmlformats.org/drawingml/2006/main" xmlns:r="http://schemas.openxmlformats.org/officeDocument/2006/relationships" xmlns:p="http://schemas.openxmlformats.org/presentationml/2006/main" embedTrueTypeFonts="1">
   <p:sldMasterIdLst>
-    <p:sldMasterId id="2147483648" r:id="rId1"/>
+    <p:sldMasterId id="2147483648" r:id="rId4"/>
   </p:sldMasterIdLst>
   <p:sldIdLst>
-    <p:sldId id="256" r:id="rId2"/>
+    <p:sldId id="256" r:id="rId5"/>
   </p:sldIdLst>
   <p:sldSz cx="32918400" cy="43891200"/>
   <p:notesSz cx="6858000" cy="9144000"/>
   <p:embeddedFontLst>
     <p:embeddedFont>
       <p:font typeface="Amaranth" panose="020B0604020202020204" charset="-94"/>
-      <p:regular r:id="rId3"/>
+      <p:regular r:id="rId6"/>
     </p:embeddedFont>
     <p:embeddedFont>
-      <p:font typeface="Montserrat Light" panose="00000400000000000000" pitchFamily="2" charset="-94"/>
-      <p:regular r:id="rId4"/>
+      <p:font typeface="Montserrat Light" panose="020F0502020204030204" pitchFamily="2" charset="-94"/>
+      <p:regular r:id="rId7"/>
     </p:embeddedFont>
     <p:embeddedFont>
       <p:font typeface="Tahoma" panose="020B0604030504040204" pitchFamily="34" charset="0"/>
-      <p:regular r:id="rId5"/>
-      <p:bold r:id="rId6"/>
+      <p:regular r:id="rId8"/>
+      <p:bold r:id="rId9"/>
     </p:embeddedFont>
     <p:embeddedFont>
-      <p:font typeface="Titillium Web" panose="00000500000000000000" pitchFamily="2" charset="-94"/>
-      <p:regular r:id="rId7"/>
+      <p:font typeface="Titillium Web" panose="020F0502020204030204" pitchFamily="2" charset="-94"/>
+      <p:regular r:id="rId10"/>
     </p:embeddedFont>
   </p:embeddedFontLst>
   <p:custDataLst>
-    <p:tags r:id="rId8"/>
+    <p:tags r:id="rId11"/>
   </p:custDataLst>
   <p:defaultTextStyle>
     <a:defPPr>
@@ -4298,15 +4298,22 @@
               <a:defRPr/>
             </a:pPr>
             <a:r>
-              <a:rPr lang="en-US" sz="4200" dirty="0">
+              <a:rPr lang="tr-TR" sz="4200" dirty="0">
                 <a:solidFill>
                   <a:schemeClr val="bg1"/>
                 </a:solidFill>
                 <a:latin typeface="Titillium Web" panose="00000500000000000000" pitchFamily="2" charset="0"/>
                 <a:cs typeface="Arial" pitchFamily="34" charset="0"/>
               </a:rPr>
-              <a:t>Full Name(s) of Student(s)</a:t>
-            </a:r>
+              <a:t>Doğukan Meral, Hamza Onur Karagür</a:t>
+            </a:r>
+            <a:endParaRPr lang="en-US" sz="4200" dirty="0">
+              <a:solidFill>
+                <a:schemeClr val="bg1"/>
+              </a:solidFill>
+              <a:latin typeface="Titillium Web" panose="00000500000000000000" pitchFamily="2" charset="0"/>
+              <a:cs typeface="Arial" pitchFamily="34" charset="0"/>
+            </a:endParaRPr>
           </a:p>
           <a:p>
             <a:pPr algn="ctr">
@@ -4320,23 +4327,47 @@
                 <a:latin typeface="Titillium Web" panose="00000500000000000000" pitchFamily="2" charset="0"/>
                 <a:cs typeface="Arial" pitchFamily="34" charset="0"/>
               </a:rPr>
-              <a:t>Supervisor: [Title, Full Name]</a:t>
-            </a:r>
-          </a:p>
-          <a:p>
-            <a:pPr algn="ctr">
-              <a:defRPr/>
-            </a:pPr>
-            <a:r>
-              <a:rPr lang="en-US" sz="4200" dirty="0">
+              <a:t>Supervisor: </a:t>
+            </a:r>
+            <a:r>
+              <a:rPr lang="tr-TR" sz="4200" dirty="0">
                 <a:solidFill>
                   <a:schemeClr val="bg1"/>
                 </a:solidFill>
                 <a:latin typeface="Titillium Web" panose="00000500000000000000" pitchFamily="2" charset="0"/>
                 <a:cs typeface="Arial" pitchFamily="34" charset="0"/>
               </a:rPr>
-              <a:t>Department Name</a:t>
-            </a:r>
+              <a:t>Dr. Öğr. Üyesi Aytun Onay</a:t>
+            </a:r>
+            <a:endParaRPr lang="en-US" sz="4200" dirty="0">
+              <a:solidFill>
+                <a:schemeClr val="bg1"/>
+              </a:solidFill>
+              <a:latin typeface="Titillium Web" panose="00000500000000000000" pitchFamily="2" charset="0"/>
+              <a:cs typeface="Arial" pitchFamily="34" charset="0"/>
+            </a:endParaRPr>
+          </a:p>
+          <a:p>
+            <a:pPr algn="ctr">
+              <a:defRPr/>
+            </a:pPr>
+            <a:r>
+              <a:rPr lang="tr-TR" sz="4200" dirty="0">
+                <a:solidFill>
+                  <a:schemeClr val="bg1"/>
+                </a:solidFill>
+                <a:latin typeface="Titillium Web" panose="00000500000000000000" pitchFamily="2" charset="0"/>
+                <a:cs typeface="Arial" pitchFamily="34" charset="0"/>
+              </a:rPr>
+              <a:t>Software Engineering</a:t>
+            </a:r>
+            <a:endParaRPr lang="en-US" sz="4200" dirty="0">
+              <a:solidFill>
+                <a:schemeClr val="bg1"/>
+              </a:solidFill>
+              <a:latin typeface="Titillium Web" panose="00000500000000000000" pitchFamily="2" charset="0"/>
+              <a:cs typeface="Arial" pitchFamily="34" charset="0"/>
+            </a:endParaRPr>
           </a:p>
         </p:txBody>
       </p:sp>
@@ -6608,6 +6639,15 @@
 </file>
 
 <file path=customXml/item1.xml><?xml version="1.0" encoding="utf-8"?>
+<?mso-contentType ?>
+<FormTemplates xmlns="http://schemas.microsoft.com/sharepoint/v3/contenttype/forms">
+  <Display>DocumentLibraryForm</Display>
+  <Edit>DocumentLibraryForm</Edit>
+  <New>DocumentLibraryForm</New>
+</FormTemplates>
+</file>
+
+<file path=customXml/item2.xml><?xml version="1.0" encoding="utf-8"?>
 <ct:contentTypeSchema xmlns:ct="http://schemas.microsoft.com/office/2006/metadata/contentType" xmlns:ma="http://schemas.microsoft.com/office/2006/metadata/properties/metaAttributes" ct:_="" ma:_="" ma:contentTypeName="Belge" ma:contentTypeID="0x010100A2D9663D32F195478084E660A9F44C9E" ma:contentTypeVersion="10" ma:contentTypeDescription="Yeni belge oluşturun." ma:contentTypeScope="" ma:versionID="6d98bf1c7ffb5fb69278a9c6338486c7">
   <xsd:schema xmlns:xsd="http://www.w3.org/2001/XMLSchema" xmlns:xs="http://www.w3.org/2001/XMLSchema" xmlns:p="http://schemas.microsoft.com/office/2006/metadata/properties" xmlns:ns2="7e9bba26-c7b2-4a27-a3ac-cd76b284cae0" xmlns:ns3="f76e5be2-97eb-4a1b-ab44-72f8057eaa93" targetNamespace="http://schemas.microsoft.com/office/2006/metadata/properties" ma:root="true" ma:fieldsID="508632a5764188408bb22ca1c81e76c3" ns2:_="" ns3:_="">
     <xsd:import namespace="7e9bba26-c7b2-4a27-a3ac-cd76b284cae0"/>
@@ -6796,15 +6836,6 @@
 </ct:contentTypeSchema>
 </file>
 
-<file path=customXml/item2.xml><?xml version="1.0" encoding="utf-8"?>
-<?mso-contentType ?>
-<FormTemplates xmlns="http://schemas.microsoft.com/sharepoint/v3/contenttype/forms">
-  <Display>DocumentLibraryForm</Display>
-  <Edit>DocumentLibraryForm</Edit>
-  <New>DocumentLibraryForm</New>
-</FormTemplates>
-</file>
-
 <file path=customXml/item3.xml><?xml version="1.0" encoding="utf-8"?>
 <p:properties xmlns:p="http://schemas.microsoft.com/office/2006/metadata/properties" xmlns:xsi="http://www.w3.org/2001/XMLSchema-instance" xmlns:pc="http://schemas.microsoft.com/office/infopath/2007/PartnerControls">
   <documentManagement>
@@ -6817,13 +6848,39 @@
 </file>
 
 <file path=customXml/itemProps1.xml><?xml version="1.0" encoding="utf-8"?>
-<ds:datastoreItem xmlns:ds="http://schemas.openxmlformats.org/officeDocument/2006/customXml" ds:itemID="{E313273B-2550-468A-8D3C-8EF0BB816CA6}"/>
+<ds:datastoreItem xmlns:ds="http://schemas.openxmlformats.org/officeDocument/2006/customXml" ds:itemID="{FD1AFEC2-01E4-469A-ACC5-AEBE441405A7}">
+  <ds:schemaRefs>
+    <ds:schemaRef ds:uri="http://schemas.microsoft.com/sharepoint/v3/contenttype/forms"/>
+  </ds:schemaRefs>
+</ds:datastoreItem>
 </file>
 
 <file path=customXml/itemProps2.xml><?xml version="1.0" encoding="utf-8"?>
-<ds:datastoreItem xmlns:ds="http://schemas.openxmlformats.org/officeDocument/2006/customXml" ds:itemID="{FD1AFEC2-01E4-469A-ACC5-AEBE441405A7}"/>
+<ds:datastoreItem xmlns:ds="http://schemas.openxmlformats.org/officeDocument/2006/customXml" ds:itemID="{E313273B-2550-468A-8D3C-8EF0BB816CA6}">
+  <ds:schemaRefs>
+    <ds:schemaRef ds:uri="http://schemas.microsoft.com/office/2006/metadata/contentType"/>
+    <ds:schemaRef ds:uri="http://schemas.microsoft.com/office/2006/metadata/properties/metaAttributes"/>
+    <ds:schemaRef ds:uri="http://www.w3.org/2001/XMLSchema"/>
+    <ds:schemaRef ds:uri="http://schemas.microsoft.com/office/2006/metadata/properties"/>
+    <ds:schemaRef ds:uri="7e9bba26-c7b2-4a27-a3ac-cd76b284cae0"/>
+    <ds:schemaRef ds:uri="f76e5be2-97eb-4a1b-ab44-72f8057eaa93"/>
+    <ds:schemaRef ds:uri="http://schemas.microsoft.com/office/2006/documentManagement/types"/>
+    <ds:schemaRef ds:uri="http://schemas.microsoft.com/office/infopath/2007/PartnerControls"/>
+    <ds:schemaRef ds:uri="http://schemas.openxmlformats.org/package/2006/metadata/core-properties"/>
+    <ds:schemaRef ds:uri="http://purl.org/dc/elements/1.1/"/>
+    <ds:schemaRef ds:uri="http://purl.org/dc/terms/"/>
+    <ds:schemaRef ds:uri="http://schemas.microsoft.com/internal/obd"/>
+  </ds:schemaRefs>
+</ds:datastoreItem>
 </file>
 
 <file path=customXml/itemProps3.xml><?xml version="1.0" encoding="utf-8"?>
-<ds:datastoreItem xmlns:ds="http://schemas.openxmlformats.org/officeDocument/2006/customXml" ds:itemID="{2E69D243-DBC8-4766-A43A-43C1845F72B7}"/>
+<ds:datastoreItem xmlns:ds="http://schemas.openxmlformats.org/officeDocument/2006/customXml" ds:itemID="{2E69D243-DBC8-4766-A43A-43C1845F72B7}">
+  <ds:schemaRefs>
+    <ds:schemaRef ds:uri="http://schemas.microsoft.com/office/2006/metadata/properties"/>
+    <ds:schemaRef ds:uri="http://schemas.microsoft.com/office/infopath/2007/PartnerControls"/>
+    <ds:schemaRef ds:uri="7e9bba26-c7b2-4a27-a3ac-cd76b284cae0"/>
+    <ds:schemaRef ds:uri="f76e5be2-97eb-4a1b-ab44-72f8057eaa93"/>
+  </ds:schemaRefs>
+</ds:datastoreItem>
 </file>
</xml_diff>

<commit_message>
Poster updated (lacks visualizations)
</commit_message>
<xml_diff>
--- a/documents/BİTİRME PROJESİ POSTER TASLAĞI.pptx
+++ b/documents/BİTİRME PROJESİ POSTER TASLAĞI.pptx
@@ -15,21 +15,25 @@
       <p:regular r:id="rId6"/>
     </p:embeddedFont>
     <p:embeddedFont>
-      <p:font typeface="Montserrat Light" panose="020F0502020204030204" pitchFamily="2" charset="-94"/>
+      <p:font typeface="Montserrat Light" panose="00000400000000000000" pitchFamily="2" charset="-94"/>
       <p:regular r:id="rId7"/>
+      <p:italic r:id="rId8"/>
     </p:embeddedFont>
     <p:embeddedFont>
       <p:font typeface="Tahoma" panose="020B0604030504040204" pitchFamily="34" charset="0"/>
-      <p:regular r:id="rId8"/>
-      <p:bold r:id="rId9"/>
+      <p:regular r:id="rId9"/>
+      <p:bold r:id="rId10"/>
     </p:embeddedFont>
     <p:embeddedFont>
-      <p:font typeface="Titillium Web" panose="020F0502020204030204" pitchFamily="2" charset="-94"/>
-      <p:regular r:id="rId10"/>
+      <p:font typeface="Titillium Web" panose="00000500000000000000" pitchFamily="2" charset="-94"/>
+      <p:regular r:id="rId11"/>
+      <p:bold r:id="rId12"/>
+      <p:italic r:id="rId13"/>
+      <p:boldItalic r:id="rId14"/>
     </p:embeddedFont>
   </p:embeddedFontLst>
   <p:custDataLst>
-    <p:tags r:id="rId11"/>
+    <p:tags r:id="rId15"/>
   </p:custDataLst>
   <p:defaultTextStyle>
     <a:defPPr>
@@ -4388,7 +4392,7 @@
         <p:spPr bwMode="auto">
           <a:xfrm>
             <a:off x="16881903" y="7393924"/>
-            <a:ext cx="15191087" cy="2713675"/>
+            <a:ext cx="15191087" cy="3146999"/>
           </a:xfrm>
           <a:prstGeom prst="rect">
             <a:avLst/>
@@ -4532,42 +4536,37 @@
             </a:lvl9pPr>
           </a:lstStyle>
           <a:p>
-            <a:pPr>
-              <a:lnSpc>
-                <a:spcPct val="150000"/>
-              </a:lnSpc>
-            </a:pPr>
-            <a:r>
-              <a:rPr lang="en-US" sz="4000" dirty="0">
-                <a:latin typeface="Tahoma" panose="020B0604030504040204" pitchFamily="34" charset="0"/>
-                <a:ea typeface="Tahoma" panose="020B0604030504040204" pitchFamily="34" charset="0"/>
-                <a:cs typeface="Tahoma" panose="020B0604030504040204" pitchFamily="34" charset="0"/>
-              </a:rPr>
-              <a:t>Add </a:t>
-            </a:r>
-            <a:r>
-              <a:rPr lang="tr-TR" sz="4000" dirty="0" err="1">
-                <a:latin typeface="Tahoma" panose="020B0604030504040204" pitchFamily="34" charset="0"/>
-                <a:ea typeface="Tahoma" panose="020B0604030504040204" pitchFamily="34" charset="0"/>
-                <a:cs typeface="Tahoma" panose="020B0604030504040204" pitchFamily="34" charset="0"/>
-              </a:rPr>
-              <a:t>the</a:t>
-            </a:r>
             <a:r>
               <a:rPr lang="tr-TR" sz="4000" dirty="0">
                 <a:latin typeface="Tahoma" panose="020B0604030504040204" pitchFamily="34" charset="0"/>
                 <a:ea typeface="Tahoma" panose="020B0604030504040204" pitchFamily="34" charset="0"/>
                 <a:cs typeface="Tahoma" panose="020B0604030504040204" pitchFamily="34" charset="0"/>
               </a:rPr>
-              <a:t> </a:t>
-            </a:r>
-            <a:r>
-              <a:rPr lang="tr-TR" sz="4000" dirty="0" err="1">
+              <a:t>-</a:t>
+            </a:r>
+            <a:r>
+              <a:rPr lang="en-GB" sz="4000" dirty="0">
                 <a:latin typeface="Tahoma" panose="020B0604030504040204" pitchFamily="34" charset="0"/>
                 <a:ea typeface="Tahoma" panose="020B0604030504040204" pitchFamily="34" charset="0"/>
                 <a:cs typeface="Tahoma" panose="020B0604030504040204" pitchFamily="34" charset="0"/>
               </a:rPr>
-              <a:t>following</a:t>
+              <a:t>Build a machine learning-driven framework to automatically optimize </a:t>
+            </a:r>
+            <a:r>
+              <a:rPr lang="en-GB" sz="4000" dirty="0" err="1">
+                <a:latin typeface="Tahoma" panose="020B0604030504040204" pitchFamily="34" charset="0"/>
+                <a:ea typeface="Tahoma" panose="020B0604030504040204" pitchFamily="34" charset="0"/>
+                <a:cs typeface="Tahoma" panose="020B0604030504040204" pitchFamily="34" charset="0"/>
+              </a:rPr>
+              <a:t>BPF</a:t>
+            </a:r>
+            <a:r>
+              <a:rPr lang="en-GB" sz="4000" dirty="0">
+                <a:latin typeface="Tahoma" panose="020B0604030504040204" pitchFamily="34" charset="0"/>
+                <a:ea typeface="Tahoma" panose="020B0604030504040204" pitchFamily="34" charset="0"/>
+                <a:cs typeface="Tahoma" panose="020B0604030504040204" pitchFamily="34" charset="0"/>
+              </a:rPr>
+              <a:t>-based CPU scheduler configurations for Linux </a:t>
             </a:r>
             <a:r>
               <a:rPr lang="tr-TR" sz="4000" dirty="0">
@@ -4575,15 +4574,15 @@
                 <a:ea typeface="Tahoma" panose="020B0604030504040204" pitchFamily="34" charset="0"/>
                 <a:cs typeface="Tahoma" panose="020B0604030504040204" pitchFamily="34" charset="0"/>
               </a:rPr>
-              <a:t> </a:t>
-            </a:r>
-            <a:r>
-              <a:rPr lang="tr-TR" sz="4000" dirty="0" err="1">
+              <a:t>’</a:t>
+            </a:r>
+            <a:r>
+              <a:rPr lang="en-GB" sz="4000" dirty="0" err="1">
                 <a:latin typeface="Tahoma" panose="020B0604030504040204" pitchFamily="34" charset="0"/>
                 <a:ea typeface="Tahoma" panose="020B0604030504040204" pitchFamily="34" charset="0"/>
                 <a:cs typeface="Tahoma" panose="020B0604030504040204" pitchFamily="34" charset="0"/>
               </a:rPr>
-              <a:t>information</a:t>
+              <a:t>sched_ext</a:t>
             </a:r>
             <a:r>
               <a:rPr lang="tr-TR" sz="4000" dirty="0">
@@ -4591,47 +4590,44 @@
                 <a:ea typeface="Tahoma" panose="020B0604030504040204" pitchFamily="34" charset="0"/>
                 <a:cs typeface="Tahoma" panose="020B0604030504040204" pitchFamily="34" charset="0"/>
               </a:rPr>
-              <a:t>: </a:t>
-            </a:r>
-          </a:p>
-          <a:p>
-            <a:pPr marL="342900" indent="-342900">
-              <a:lnSpc>
-                <a:spcPct val="150000"/>
-              </a:lnSpc>
-              <a:buFont typeface="Arial" panose="020B0604020202020204" pitchFamily="34" charset="0"/>
-              <a:buChar char="•"/>
-            </a:pPr>
-            <a:r>
-              <a:rPr lang="en-US" sz="4000" dirty="0">
+              <a:t>’.</a:t>
+            </a:r>
+            <a:endParaRPr lang="en-GB" sz="4000" dirty="0">
+              <a:latin typeface="Tahoma" panose="020B0604030504040204" pitchFamily="34" charset="0"/>
+              <a:ea typeface="Tahoma" panose="020B0604030504040204" pitchFamily="34" charset="0"/>
+              <a:cs typeface="Tahoma" panose="020B0604030504040204" pitchFamily="34" charset="0"/>
+            </a:endParaRPr>
+          </a:p>
+          <a:p>
+            <a:r>
+              <a:rPr lang="tr-TR" sz="4000" dirty="0">
                 <a:latin typeface="Tahoma" panose="020B0604030504040204" pitchFamily="34" charset="0"/>
                 <a:ea typeface="Tahoma" panose="020B0604030504040204" pitchFamily="34" charset="0"/>
                 <a:cs typeface="Tahoma" panose="020B0604030504040204" pitchFamily="34" charset="0"/>
               </a:rPr>
-              <a:t>Clearly defined project goals</a:t>
-            </a:r>
-            <a:endParaRPr lang="tr-TR" sz="4000" dirty="0">
+              <a:t>-</a:t>
+            </a:r>
+            <a:r>
+              <a:rPr lang="en-GB" sz="4000" dirty="0">
+                <a:latin typeface="Tahoma" panose="020B0604030504040204" pitchFamily="34" charset="0"/>
+                <a:ea typeface="Tahoma" panose="020B0604030504040204" pitchFamily="34" charset="0"/>
+                <a:cs typeface="Tahoma" panose="020B0604030504040204" pitchFamily="34" charset="0"/>
+              </a:rPr>
+              <a:t>Enable adaptive performance tuning across multiple workload types</a:t>
+            </a:r>
+            <a:r>
+              <a:rPr lang="tr-TR" sz="4000" dirty="0">
+                <a:latin typeface="Tahoma" panose="020B0604030504040204" pitchFamily="34" charset="0"/>
+                <a:ea typeface="Tahoma" panose="020B0604030504040204" pitchFamily="34" charset="0"/>
+                <a:cs typeface="Tahoma" panose="020B0604030504040204" pitchFamily="34" charset="0"/>
+              </a:rPr>
+              <a:t>.</a:t>
+            </a:r>
+            <a:endParaRPr lang="en-GB" sz="4000" dirty="0">
               <a:latin typeface="Tahoma" panose="020B0604030504040204" pitchFamily="34" charset="0"/>
               <a:ea typeface="Tahoma" panose="020B0604030504040204" pitchFamily="34" charset="0"/>
               <a:cs typeface="Tahoma" panose="020B0604030504040204" pitchFamily="34" charset="0"/>
             </a:endParaRPr>
-          </a:p>
-          <a:p>
-            <a:pPr marL="342900" indent="-342900">
-              <a:lnSpc>
-                <a:spcPct val="150000"/>
-              </a:lnSpc>
-              <a:buFont typeface="Arial" panose="020B0604020202020204" pitchFamily="34" charset="0"/>
-              <a:buChar char="•"/>
-            </a:pPr>
-            <a:r>
-              <a:rPr lang="en-US" sz="4000" dirty="0">
-                <a:latin typeface="Tahoma" panose="020B0604030504040204" pitchFamily="34" charset="0"/>
-                <a:ea typeface="Tahoma" panose="020B0604030504040204" pitchFamily="34" charset="0"/>
-                <a:cs typeface="Tahoma" panose="020B0604030504040204" pitchFamily="34" charset="0"/>
-              </a:rPr>
-              <a:t>Research questions or hypotheses (if applicable).</a:t>
-            </a:r>
           </a:p>
         </p:txBody>
       </p:sp>
@@ -4652,7 +4648,7 @@
         <p:spPr bwMode="auto">
           <a:xfrm>
             <a:off x="17247664" y="17877978"/>
-            <a:ext cx="15191087" cy="2762278"/>
+            <a:ext cx="15191087" cy="3146999"/>
           </a:xfrm>
           <a:prstGeom prst="rect">
             <a:avLst/>
@@ -4796,64 +4792,105 @@
             </a:lvl9pPr>
           </a:lstStyle>
           <a:p>
-            <a:pPr algn="just">
-              <a:lnSpc>
-                <a:spcPct val="110000"/>
-              </a:lnSpc>
-            </a:pPr>
-            <a:r>
-              <a:rPr lang="en-US" sz="4000" dirty="0">
+            <a:r>
+              <a:rPr lang="tr-TR" sz="4000" dirty="0">
                 <a:latin typeface="Tahoma" panose="020B0604030504040204" pitchFamily="34" charset="0"/>
                 <a:ea typeface="Tahoma" panose="020B0604030504040204" pitchFamily="34" charset="0"/>
                 <a:cs typeface="Tahoma" panose="020B0604030504040204" pitchFamily="34" charset="0"/>
               </a:rPr>
-              <a:t>Add the following information: </a:t>
-            </a:r>
-          </a:p>
-          <a:p>
-            <a:pPr algn="just">
-              <a:lnSpc>
-                <a:spcPct val="110000"/>
-              </a:lnSpc>
-            </a:pPr>
-            <a:r>
-              <a:rPr lang="en-US" sz="4000" dirty="0">
+              <a:t>-</a:t>
+            </a:r>
+            <a:r>
+              <a:rPr lang="en-GB" sz="4000" dirty="0">
                 <a:latin typeface="Tahoma" panose="020B0604030504040204" pitchFamily="34" charset="0"/>
                 <a:ea typeface="Tahoma" panose="020B0604030504040204" pitchFamily="34" charset="0"/>
                 <a:cs typeface="Tahoma" panose="020B0604030504040204" pitchFamily="34" charset="0"/>
               </a:rPr>
-              <a:t>Summary of achievements</a:t>
-            </a:r>
-          </a:p>
-          <a:p>
-            <a:pPr algn="just">
-              <a:lnSpc>
-                <a:spcPct val="110000"/>
-              </a:lnSpc>
-            </a:pPr>
-            <a:r>
-              <a:rPr lang="en-US" sz="4000" dirty="0">
+              <a:t>Benchmarked 8+ scheduler variants across 3 workload categories</a:t>
+            </a:r>
+            <a:r>
+              <a:rPr lang="tr-TR" sz="4000" dirty="0">
                 <a:latin typeface="Tahoma" panose="020B0604030504040204" pitchFamily="34" charset="0"/>
                 <a:ea typeface="Tahoma" panose="020B0604030504040204" pitchFamily="34" charset="0"/>
                 <a:cs typeface="Tahoma" panose="020B0604030504040204" pitchFamily="34" charset="0"/>
               </a:rPr>
-              <a:t>Key takeaways</a:t>
-            </a:r>
-          </a:p>
-          <a:p>
-            <a:pPr algn="just">
-              <a:lnSpc>
-                <a:spcPct val="110000"/>
-              </a:lnSpc>
-            </a:pPr>
-            <a:r>
-              <a:rPr lang="en-US" sz="4000" dirty="0">
+              <a:t>.</a:t>
+            </a:r>
+            <a:endParaRPr lang="en-GB" sz="4000" dirty="0">
+              <a:latin typeface="Tahoma" panose="020B0604030504040204" pitchFamily="34" charset="0"/>
+              <a:ea typeface="Tahoma" panose="020B0604030504040204" pitchFamily="34" charset="0"/>
+              <a:cs typeface="Tahoma" panose="020B0604030504040204" pitchFamily="34" charset="0"/>
+            </a:endParaRPr>
+          </a:p>
+          <a:p>
+            <a:r>
+              <a:rPr lang="tr-TR" sz="4000">
                 <a:latin typeface="Tahoma" panose="020B0604030504040204" pitchFamily="34" charset="0"/>
                 <a:ea typeface="Tahoma" panose="020B0604030504040204" pitchFamily="34" charset="0"/>
                 <a:cs typeface="Tahoma" panose="020B0604030504040204" pitchFamily="34" charset="0"/>
               </a:rPr>
-              <a:t>Contributions of the project</a:t>
-            </a:r>
+              <a:t>-</a:t>
+            </a:r>
+            <a:r>
+              <a:rPr lang="en-GB" sz="4000">
+                <a:latin typeface="Tahoma" panose="020B0604030504040204" pitchFamily="34" charset="0"/>
+                <a:ea typeface="Tahoma" panose="020B0604030504040204" pitchFamily="34" charset="0"/>
+                <a:cs typeface="Tahoma" panose="020B0604030504040204" pitchFamily="34" charset="0"/>
+              </a:rPr>
+              <a:t>Demonstrated </a:t>
+            </a:r>
+            <a:r>
+              <a:rPr lang="en-GB" sz="4000" dirty="0">
+                <a:latin typeface="Tahoma" panose="020B0604030504040204" pitchFamily="34" charset="0"/>
+                <a:ea typeface="Tahoma" panose="020B0604030504040204" pitchFamily="34" charset="0"/>
+                <a:cs typeface="Tahoma" panose="020B0604030504040204" pitchFamily="34" charset="0"/>
+              </a:rPr>
+              <a:t>measurable performance improvements through adaptive configuration</a:t>
+            </a:r>
+            <a:r>
+              <a:rPr lang="tr-TR" sz="4000" dirty="0">
+                <a:latin typeface="Tahoma" panose="020B0604030504040204" pitchFamily="34" charset="0"/>
+                <a:ea typeface="Tahoma" panose="020B0604030504040204" pitchFamily="34" charset="0"/>
+                <a:cs typeface="Tahoma" panose="020B0604030504040204" pitchFamily="34" charset="0"/>
+              </a:rPr>
+              <a:t>.</a:t>
+            </a:r>
+            <a:endParaRPr lang="en-GB" sz="4000" dirty="0">
+              <a:latin typeface="Tahoma" panose="020B0604030504040204" pitchFamily="34" charset="0"/>
+              <a:ea typeface="Tahoma" panose="020B0604030504040204" pitchFamily="34" charset="0"/>
+              <a:cs typeface="Tahoma" panose="020B0604030504040204" pitchFamily="34" charset="0"/>
+            </a:endParaRPr>
+          </a:p>
+          <a:p>
+            <a:r>
+              <a:rPr lang="tr-TR" sz="4000" dirty="0">
+                <a:latin typeface="Tahoma" panose="020B0604030504040204" pitchFamily="34" charset="0"/>
+                <a:ea typeface="Tahoma" panose="020B0604030504040204" pitchFamily="34" charset="0"/>
+                <a:cs typeface="Tahoma" panose="020B0604030504040204" pitchFamily="34" charset="0"/>
+              </a:rPr>
+              <a:t>-</a:t>
+            </a:r>
+            <a:r>
+              <a:rPr lang="en-GB" sz="4000" dirty="0">
+                <a:latin typeface="Tahoma" panose="020B0604030504040204" pitchFamily="34" charset="0"/>
+                <a:ea typeface="Tahoma" panose="020B0604030504040204" pitchFamily="34" charset="0"/>
+                <a:cs typeface="Tahoma" panose="020B0604030504040204" pitchFamily="34" charset="0"/>
+              </a:rPr>
+              <a:t>Delivered a reproducible testing environment with automated data collection and analysis</a:t>
+            </a:r>
+            <a:r>
+              <a:rPr lang="tr-TR" sz="4000" dirty="0">
+                <a:latin typeface="Tahoma" panose="020B0604030504040204" pitchFamily="34" charset="0"/>
+                <a:ea typeface="Tahoma" panose="020B0604030504040204" pitchFamily="34" charset="0"/>
+                <a:cs typeface="Tahoma" panose="020B0604030504040204" pitchFamily="34" charset="0"/>
+              </a:rPr>
+              <a:t>.</a:t>
+            </a:r>
+            <a:endParaRPr lang="en-GB" sz="4000" dirty="0">
+              <a:latin typeface="Tahoma" panose="020B0604030504040204" pitchFamily="34" charset="0"/>
+              <a:ea typeface="Tahoma" panose="020B0604030504040204" pitchFamily="34" charset="0"/>
+              <a:cs typeface="Tahoma" panose="020B0604030504040204" pitchFamily="34" charset="0"/>
+            </a:endParaRPr>
           </a:p>
         </p:txBody>
       </p:sp>
@@ -5136,7 +5173,7 @@
         <p:spPr bwMode="auto">
           <a:xfrm>
             <a:off x="839547" y="7454217"/>
-            <a:ext cx="15191087" cy="3439387"/>
+            <a:ext cx="15191087" cy="4745001"/>
           </a:xfrm>
           <a:prstGeom prst="rect">
             <a:avLst/>
@@ -5286,89 +5323,18 @@
               </a:lnSpc>
             </a:pPr>
             <a:r>
-              <a:rPr lang="en-US" sz="4000" dirty="0">
-                <a:latin typeface="Tahoma" panose="020B0604030504040204" pitchFamily="34" charset="0"/>
-                <a:ea typeface="Tahoma" panose="020B0604030504040204" pitchFamily="34" charset="0"/>
-                <a:cs typeface="Tahoma" panose="020B0604030504040204" pitchFamily="34" charset="0"/>
-              </a:rPr>
-              <a:t>Add a brief summary of the project (50–</a:t>
-            </a:r>
-            <a:r>
               <a:rPr lang="tr-TR" sz="4000" dirty="0">
                 <a:latin typeface="Tahoma" panose="020B0604030504040204" pitchFamily="34" charset="0"/>
                 <a:ea typeface="Tahoma" panose="020B0604030504040204" pitchFamily="34" charset="0"/>
                 <a:cs typeface="Tahoma" panose="020B0604030504040204" pitchFamily="34" charset="0"/>
               </a:rPr>
-              <a:t>10</a:t>
-            </a:r>
-            <a:r>
-              <a:rPr lang="en-US" sz="4000" dirty="0">
-                <a:latin typeface="Tahoma" panose="020B0604030504040204" pitchFamily="34" charset="0"/>
-                <a:ea typeface="Tahoma" panose="020B0604030504040204" pitchFamily="34" charset="0"/>
-                <a:cs typeface="Tahoma" panose="020B0604030504040204" pitchFamily="34" charset="0"/>
-              </a:rPr>
-              <a:t>0 words), including: </a:t>
-            </a:r>
-          </a:p>
-          <a:p>
-            <a:pPr algn="just">
-              <a:lnSpc>
-                <a:spcPct val="110000"/>
-              </a:lnSpc>
-            </a:pPr>
-            <a:r>
-              <a:rPr lang="en-US" sz="4000" dirty="0">
-                <a:latin typeface="Tahoma" panose="020B0604030504040204" pitchFamily="34" charset="0"/>
-                <a:ea typeface="Tahoma" panose="020B0604030504040204" pitchFamily="34" charset="0"/>
-                <a:cs typeface="Tahoma" panose="020B0604030504040204" pitchFamily="34" charset="0"/>
-              </a:rPr>
-              <a:t>Problem statement, </a:t>
-            </a:r>
-          </a:p>
-          <a:p>
-            <a:pPr algn="just">
-              <a:lnSpc>
-                <a:spcPct val="110000"/>
-              </a:lnSpc>
-            </a:pPr>
-            <a:r>
-              <a:rPr lang="en-US" sz="4000" dirty="0">
-                <a:latin typeface="Tahoma" panose="020B0604030504040204" pitchFamily="34" charset="0"/>
-                <a:ea typeface="Tahoma" panose="020B0604030504040204" pitchFamily="34" charset="0"/>
-                <a:cs typeface="Tahoma" panose="020B0604030504040204" pitchFamily="34" charset="0"/>
-              </a:rPr>
-              <a:t>Objectives, </a:t>
-            </a:r>
-          </a:p>
-          <a:p>
-            <a:pPr algn="just">
-              <a:lnSpc>
-                <a:spcPct val="110000"/>
-              </a:lnSpc>
-            </a:pPr>
-            <a:r>
-              <a:rPr lang="en-US" sz="4000" dirty="0">
-                <a:latin typeface="Tahoma" panose="020B0604030504040204" pitchFamily="34" charset="0"/>
-                <a:ea typeface="Tahoma" panose="020B0604030504040204" pitchFamily="34" charset="0"/>
-                <a:cs typeface="Tahoma" panose="020B0604030504040204" pitchFamily="34" charset="0"/>
-              </a:rPr>
-              <a:t>Methods, </a:t>
-            </a:r>
-          </a:p>
-          <a:p>
-            <a:pPr algn="just">
-              <a:lnSpc>
-                <a:spcPct val="110000"/>
-              </a:lnSpc>
-            </a:pPr>
-            <a:r>
-              <a:rPr lang="en-US" sz="4000" dirty="0">
-                <a:latin typeface="Tahoma" panose="020B0604030504040204" pitchFamily="34" charset="0"/>
-                <a:ea typeface="Tahoma" panose="020B0604030504040204" pitchFamily="34" charset="0"/>
-                <a:cs typeface="Tahoma" panose="020B0604030504040204" pitchFamily="34" charset="0"/>
-              </a:rPr>
-              <a:t>Key results, </a:t>
-            </a:r>
+              <a:t>Linux CPU schedulers require optimal configuration to balance performance across diverse workloads. Manual tuning is inefficient and non-adaptive to changing system conditions. Our objective is to develop a machine learning-driven framework to automatically optimize BPF-based CPU scheduler configurations for Linux sched_ext, enabling adaptive performance across multiple workload types.</a:t>
+            </a:r>
+            <a:endParaRPr lang="en-US" sz="4000" dirty="0">
+              <a:latin typeface="Tahoma" panose="020B0604030504040204" pitchFamily="34" charset="0"/>
+              <a:ea typeface="Tahoma" panose="020B0604030504040204" pitchFamily="34" charset="0"/>
+              <a:cs typeface="Tahoma" panose="020B0604030504040204" pitchFamily="34" charset="0"/>
+            </a:endParaRPr>
           </a:p>
         </p:txBody>
       </p:sp>
@@ -5750,6 +5716,389 @@
           </a:p>
           <a:p>
             <a:endParaRPr lang="tr-TR" dirty="0"/>
+          </a:p>
+        </p:txBody>
+      </p:sp>
+      <p:grpSp>
+        <p:nvGrpSpPr>
+          <p:cNvPr id="3" name="Group 2">
+            <a:extLst>
+              <a:ext uri="{FF2B5EF4-FFF2-40B4-BE49-F238E27FC236}">
+                <a16:creationId xmlns:a16="http://schemas.microsoft.com/office/drawing/2014/main" id="{9C6A8C6E-6DED-F536-6DEC-24E5488DCB58}"/>
+              </a:ext>
+            </a:extLst>
+          </p:cNvPr>
+          <p:cNvGrpSpPr/>
+          <p:nvPr/>
+        </p:nvGrpSpPr>
+        <p:grpSpPr>
+          <a:xfrm>
+            <a:off x="845409" y="13248040"/>
+            <a:ext cx="3765214" cy="923330"/>
+            <a:chOff x="822963" y="5867404"/>
+            <a:chExt cx="3765214" cy="923330"/>
+          </a:xfrm>
+        </p:grpSpPr>
+        <p:sp>
+          <p:nvSpPr>
+            <p:cNvPr id="4" name="TextBox 3">
+              <a:extLst>
+                <a:ext uri="{FF2B5EF4-FFF2-40B4-BE49-F238E27FC236}">
+                  <a16:creationId xmlns:a16="http://schemas.microsoft.com/office/drawing/2014/main" id="{44395DBB-C7BA-B349-8C01-C2DDB0DFA19E}"/>
+                </a:ext>
+              </a:extLst>
+            </p:cNvPr>
+            <p:cNvSpPr txBox="1"/>
+            <p:nvPr/>
+          </p:nvSpPr>
+          <p:spPr>
+            <a:xfrm>
+              <a:off x="1188720" y="5867404"/>
+              <a:ext cx="3399457" cy="923330"/>
+            </a:xfrm>
+            <a:prstGeom prst="rect">
+              <a:avLst/>
+            </a:prstGeom>
+            <a:ln>
+              <a:noFill/>
+            </a:ln>
+            <a:effectLst/>
+          </p:spPr>
+          <p:style>
+            <a:lnRef idx="2">
+              <a:schemeClr val="dk1"/>
+            </a:lnRef>
+            <a:fillRef idx="1">
+              <a:schemeClr val="lt1"/>
+            </a:fillRef>
+            <a:effectRef idx="0">
+              <a:schemeClr val="dk1"/>
+            </a:effectRef>
+            <a:fontRef idx="minor">
+              <a:schemeClr val="dk1"/>
+            </a:fontRef>
+          </p:style>
+          <p:txBody>
+            <a:bodyPr wrap="none" lIns="205740" rIns="205740" rtlCol="0">
+              <a:spAutoFit/>
+            </a:bodyPr>
+            <a:lstStyle/>
+            <a:p>
+              <a:pPr defTabSz="3526941">
+                <a:defRPr/>
+              </a:pPr>
+              <a:r>
+                <a:rPr lang="tr-TR" sz="5400" dirty="0">
+                  <a:solidFill>
+                    <a:schemeClr val="tx2">
+                      <a:lumMod val="60000"/>
+                      <a:lumOff val="40000"/>
+                    </a:schemeClr>
+                  </a:solidFill>
+                  <a:latin typeface="Amaranth" panose="02000503050000020004" pitchFamily="2" charset="0"/>
+                </a:rPr>
+                <a:t>METHODS</a:t>
+              </a:r>
+              <a:endParaRPr lang="en-US" sz="5400" dirty="0">
+                <a:solidFill>
+                  <a:schemeClr val="tx2">
+                    <a:lumMod val="60000"/>
+                    <a:lumOff val="40000"/>
+                  </a:schemeClr>
+                </a:solidFill>
+                <a:latin typeface="Amaranth" panose="02000503050000020004" pitchFamily="2" charset="0"/>
+              </a:endParaRPr>
+            </a:p>
+          </p:txBody>
+        </p:sp>
+        <p:sp>
+          <p:nvSpPr>
+            <p:cNvPr id="6" name="Rectangle 5">
+              <a:extLst>
+                <a:ext uri="{FF2B5EF4-FFF2-40B4-BE49-F238E27FC236}">
+                  <a16:creationId xmlns:a16="http://schemas.microsoft.com/office/drawing/2014/main" id="{3A5692EE-B1AD-4E91-CF92-60B4C54F9CCC}"/>
+                </a:ext>
+              </a:extLst>
+            </p:cNvPr>
+            <p:cNvSpPr/>
+            <p:nvPr/>
+          </p:nvSpPr>
+          <p:spPr bwMode="auto">
+            <a:xfrm>
+              <a:off x="822963" y="5948195"/>
+              <a:ext cx="365760" cy="457200"/>
+            </a:xfrm>
+            <a:prstGeom prst="rect">
+              <a:avLst/>
+            </a:prstGeom>
+            <a:solidFill>
+              <a:schemeClr val="tx2">
+                <a:lumMod val="60000"/>
+                <a:lumOff val="40000"/>
+              </a:schemeClr>
+            </a:solidFill>
+            <a:ln w="9525" cap="flat" cmpd="sng" algn="ctr">
+              <a:noFill/>
+              <a:prstDash val="solid"/>
+              <a:round/>
+              <a:headEnd type="none" w="med" len="med"/>
+              <a:tailEnd type="none" w="med" len="med"/>
+            </a:ln>
+            <a:effectLst/>
+          </p:spPr>
+          <p:txBody>
+            <a:bodyPr vert="horz" wrap="square" lIns="68580" tIns="34290" rIns="68580" bIns="34290" numCol="1" rtlCol="0" anchor="t" anchorCtr="0" compatLnSpc="1">
+              <a:prstTxWarp prst="textNoShape">
+                <a:avLst/>
+              </a:prstTxWarp>
+            </a:bodyPr>
+            <a:lstStyle/>
+            <a:p>
+              <a:pPr defTabSz="3527822"/>
+              <a:endParaRPr lang="en-US" sz="3600" dirty="0">
+                <a:solidFill>
+                  <a:schemeClr val="tx2">
+                    <a:lumMod val="60000"/>
+                    <a:lumOff val="40000"/>
+                  </a:schemeClr>
+                </a:solidFill>
+                <a:latin typeface="Arial" pitchFamily="34" charset="0"/>
+              </a:endParaRPr>
+            </a:p>
+          </p:txBody>
+        </p:sp>
+      </p:grpSp>
+      <p:sp>
+        <p:nvSpPr>
+          <p:cNvPr id="9" name="TextBox 19">
+            <a:extLst>
+              <a:ext uri="{FF2B5EF4-FFF2-40B4-BE49-F238E27FC236}">
+                <a16:creationId xmlns:a16="http://schemas.microsoft.com/office/drawing/2014/main" id="{469EAF54-4D61-8580-D844-912E9ECD858C}"/>
+              </a:ext>
+            </a:extLst>
+          </p:cNvPr>
+          <p:cNvSpPr txBox="1">
+            <a:spLocks noChangeArrowheads="1"/>
+          </p:cNvSpPr>
+          <p:nvPr/>
+        </p:nvSpPr>
+        <p:spPr bwMode="auto">
+          <a:xfrm>
+            <a:off x="806896" y="14679719"/>
+            <a:ext cx="15191087" cy="4993659"/>
+          </a:xfrm>
+          <a:prstGeom prst="rect">
+            <a:avLst/>
+          </a:prstGeom>
+          <a:noFill/>
+          <a:ln>
+            <a:noFill/>
+          </a:ln>
+          <a:extLst>
+            <a:ext uri="{909E8E84-426E-40DD-AFC4-6F175D3DCCD1}">
+              <a14:hiddenFill xmlns:a14="http://schemas.microsoft.com/office/drawing/2010/main">
+                <a:solidFill>
+                  <a:srgbClr val="FFFFFF"/>
+                </a:solidFill>
+              </a14:hiddenFill>
+            </a:ext>
+            <a:ext uri="{91240B29-F687-4F45-9708-019B960494DF}">
+              <a14:hiddenLine xmlns:a14="http://schemas.microsoft.com/office/drawing/2010/main" w="9525">
+                <a:solidFill>
+                  <a:srgbClr val="000000"/>
+                </a:solidFill>
+                <a:miter lim="800000"/>
+                <a:headEnd/>
+                <a:tailEnd/>
+              </a14:hiddenLine>
+            </a:ext>
+          </a:extLst>
+        </p:spPr>
+        <p:txBody>
+          <a:bodyPr wrap="square" lIns="68564" tIns="34282" rIns="68564" bIns="34282">
+            <a:spAutoFit/>
+          </a:bodyPr>
+          <a:lstStyle>
+            <a:defPPr>
+              <a:defRPr kern="1200"/>
+            </a:defPPr>
+            <a:lvl1pPr eaLnBrk="0" hangingPunct="0">
+              <a:defRPr sz="2000">
+                <a:solidFill>
+                  <a:schemeClr val="tx1"/>
+                </a:solidFill>
+                <a:latin typeface="Arial"/>
+                <a:ea typeface="ＭＳ Ｐゴシック" pitchFamily="-106" charset="-128"/>
+              </a:defRPr>
+            </a:lvl1pPr>
+            <a:lvl2pPr eaLnBrk="0" hangingPunct="0">
+              <a:defRPr sz="2000">
+                <a:solidFill>
+                  <a:schemeClr val="tx1"/>
+                </a:solidFill>
+                <a:latin typeface="Arial"/>
+                <a:ea typeface="ＭＳ Ｐゴシック" pitchFamily="-106" charset="-128"/>
+              </a:defRPr>
+            </a:lvl2pPr>
+            <a:lvl3pPr marL="1143000" indent="-228600" eaLnBrk="0" hangingPunct="0">
+              <a:defRPr sz="2000">
+                <a:solidFill>
+                  <a:schemeClr val="tx1"/>
+                </a:solidFill>
+                <a:latin typeface="Arial"/>
+                <a:ea typeface="ＭＳ Ｐゴシック" pitchFamily="-106" charset="-128"/>
+              </a:defRPr>
+            </a:lvl3pPr>
+            <a:lvl4pPr marL="1600200" indent="-228600" eaLnBrk="0" hangingPunct="0">
+              <a:defRPr sz="2000">
+                <a:solidFill>
+                  <a:schemeClr val="tx1"/>
+                </a:solidFill>
+                <a:latin typeface="Arial"/>
+                <a:ea typeface="ＭＳ Ｐゴシック" pitchFamily="-106" charset="-128"/>
+              </a:defRPr>
+            </a:lvl4pPr>
+            <a:lvl5pPr marL="2057400" indent="-228600" eaLnBrk="0" hangingPunct="0">
+              <a:defRPr sz="2000">
+                <a:solidFill>
+                  <a:schemeClr val="tx1"/>
+                </a:solidFill>
+                <a:latin typeface="Arial"/>
+                <a:ea typeface="ＭＳ Ｐゴシック" pitchFamily="-106" charset="-128"/>
+              </a:defRPr>
+            </a:lvl5pPr>
+            <a:lvl6pPr marL="2514600" indent="-228600" eaLnBrk="0" fontAlgn="base" hangingPunct="0">
+              <a:spcBef>
+                <a:spcPct val="0"/>
+              </a:spcBef>
+              <a:spcAft>
+                <a:spcPct val="0"/>
+              </a:spcAft>
+              <a:defRPr sz="2000">
+                <a:solidFill>
+                  <a:schemeClr val="tx1"/>
+                </a:solidFill>
+                <a:latin typeface="Arial"/>
+                <a:ea typeface="ＭＳ Ｐゴシック" pitchFamily="-106" charset="-128"/>
+              </a:defRPr>
+            </a:lvl6pPr>
+            <a:lvl7pPr marL="2971800" indent="-228600" eaLnBrk="0" fontAlgn="base" hangingPunct="0">
+              <a:spcBef>
+                <a:spcPct val="0"/>
+              </a:spcBef>
+              <a:spcAft>
+                <a:spcPct val="0"/>
+              </a:spcAft>
+              <a:defRPr sz="2000">
+                <a:solidFill>
+                  <a:schemeClr val="tx1"/>
+                </a:solidFill>
+                <a:latin typeface="Arial"/>
+                <a:ea typeface="ＭＳ Ｐゴシック" pitchFamily="-106" charset="-128"/>
+              </a:defRPr>
+            </a:lvl7pPr>
+            <a:lvl8pPr marL="3429000" indent="-228600" eaLnBrk="0" fontAlgn="base" hangingPunct="0">
+              <a:spcBef>
+                <a:spcPct val="0"/>
+              </a:spcBef>
+              <a:spcAft>
+                <a:spcPct val="0"/>
+              </a:spcAft>
+              <a:defRPr sz="2000">
+                <a:solidFill>
+                  <a:schemeClr val="tx1"/>
+                </a:solidFill>
+                <a:latin typeface="Arial"/>
+                <a:ea typeface="ＭＳ Ｐゴシック" pitchFamily="-106" charset="-128"/>
+              </a:defRPr>
+            </a:lvl8pPr>
+            <a:lvl9pPr marL="3886200" indent="-228600" eaLnBrk="0" fontAlgn="base" hangingPunct="0">
+              <a:spcBef>
+                <a:spcPct val="0"/>
+              </a:spcBef>
+              <a:spcAft>
+                <a:spcPct val="0"/>
+              </a:spcAft>
+              <a:defRPr sz="2000">
+                <a:solidFill>
+                  <a:schemeClr val="tx1"/>
+                </a:solidFill>
+                <a:latin typeface="Arial"/>
+                <a:ea typeface="ＭＳ Ｐゴシック" pitchFamily="-106" charset="-128"/>
+              </a:defRPr>
+            </a:lvl9pPr>
+          </a:lstStyle>
+          <a:p>
+            <a:r>
+              <a:rPr lang="en-GB" sz="4000" dirty="0">
+                <a:latin typeface="Tahoma" panose="020B0604030504040204" pitchFamily="34" charset="0"/>
+                <a:ea typeface="Tahoma" panose="020B0604030504040204" pitchFamily="34" charset="0"/>
+                <a:cs typeface="Tahoma" panose="020B0604030504040204" pitchFamily="34" charset="0"/>
+              </a:rPr>
+              <a:t>- Implemented multiple </a:t>
+            </a:r>
+            <a:r>
+              <a:rPr lang="en-GB" sz="4000" dirty="0" err="1">
+                <a:latin typeface="Tahoma" panose="020B0604030504040204" pitchFamily="34" charset="0"/>
+                <a:ea typeface="Tahoma" panose="020B0604030504040204" pitchFamily="34" charset="0"/>
+                <a:cs typeface="Tahoma" panose="020B0604030504040204" pitchFamily="34" charset="0"/>
+              </a:rPr>
+              <a:t>BPF</a:t>
+            </a:r>
+            <a:r>
+              <a:rPr lang="en-GB" sz="4000" dirty="0">
+                <a:latin typeface="Tahoma" panose="020B0604030504040204" pitchFamily="34" charset="0"/>
+                <a:ea typeface="Tahoma" panose="020B0604030504040204" pitchFamily="34" charset="0"/>
+                <a:cs typeface="Tahoma" panose="020B0604030504040204" pitchFamily="34" charset="0"/>
+              </a:rPr>
+              <a:t>-based schedulers using </a:t>
+            </a:r>
+            <a:r>
+              <a:rPr lang="en-GB" sz="4000" dirty="0" err="1">
+                <a:latin typeface="Tahoma" panose="020B0604030504040204" pitchFamily="34" charset="0"/>
+                <a:ea typeface="Tahoma" panose="020B0604030504040204" pitchFamily="34" charset="0"/>
+                <a:cs typeface="Tahoma" panose="020B0604030504040204" pitchFamily="34" charset="0"/>
+              </a:rPr>
+              <a:t>libbpf</a:t>
+            </a:r>
+            <a:r>
+              <a:rPr lang="en-GB" sz="4000" dirty="0">
+                <a:latin typeface="Tahoma" panose="020B0604030504040204" pitchFamily="34" charset="0"/>
+                <a:ea typeface="Tahoma" panose="020B0604030504040204" pitchFamily="34" charset="0"/>
+                <a:cs typeface="Tahoma" panose="020B0604030504040204" pitchFamily="34" charset="0"/>
+              </a:rPr>
+              <a:t> and kernel tracing</a:t>
+            </a:r>
+          </a:p>
+          <a:p>
+            <a:r>
+              <a:rPr lang="en-GB" sz="4000" dirty="0">
+                <a:latin typeface="Tahoma" panose="020B0604030504040204" pitchFamily="34" charset="0"/>
+                <a:ea typeface="Tahoma" panose="020B0604030504040204" pitchFamily="34" charset="0"/>
+                <a:cs typeface="Tahoma" panose="020B0604030504040204" pitchFamily="34" charset="0"/>
+              </a:rPr>
+              <a:t>- Collected performance metrics across diverse workloads (git compilation, PostgreSQL benchmarks, gaming)</a:t>
+            </a:r>
+          </a:p>
+          <a:p>
+            <a:r>
+              <a:rPr lang="en-GB" sz="4000" dirty="0">
+                <a:latin typeface="Tahoma" panose="020B0604030504040204" pitchFamily="34" charset="0"/>
+                <a:ea typeface="Tahoma" panose="020B0604030504040204" pitchFamily="34" charset="0"/>
+                <a:cs typeface="Tahoma" panose="020B0604030504040204" pitchFamily="34" charset="0"/>
+              </a:rPr>
+              <a:t>- Generated comprehensive datasets with CPU utilization, latency, and timing histograms</a:t>
+            </a:r>
+          </a:p>
+          <a:p>
+            <a:r>
+              <a:rPr lang="en-GB" sz="4000" dirty="0">
+                <a:latin typeface="Tahoma" panose="020B0604030504040204" pitchFamily="34" charset="0"/>
+                <a:ea typeface="Tahoma" panose="020B0604030504040204" pitchFamily="34" charset="0"/>
+                <a:cs typeface="Tahoma" panose="020B0604030504040204" pitchFamily="34" charset="0"/>
+              </a:rPr>
+              <a:t>- Applied machine learning techniques to identify optimal scheduler configurations</a:t>
+            </a:r>
           </a:p>
         </p:txBody>
       </p:sp>
@@ -6648,6 +6997,17 @@
 </file>
 
 <file path=customXml/item2.xml><?xml version="1.0" encoding="utf-8"?>
+<p:properties xmlns:p="http://schemas.microsoft.com/office/2006/metadata/properties" xmlns:xsi="http://www.w3.org/2001/XMLSchema-instance" xmlns:pc="http://schemas.microsoft.com/office/infopath/2007/PartnerControls">
+  <documentManagement>
+    <lcf76f155ced4ddcb4097134ff3c332f xmlns="7e9bba26-c7b2-4a27-a3ac-cd76b284cae0">
+      <Terms xmlns="http://schemas.microsoft.com/office/infopath/2007/PartnerControls"/>
+    </lcf76f155ced4ddcb4097134ff3c332f>
+    <TaxCatchAll xmlns="f76e5be2-97eb-4a1b-ab44-72f8057eaa93" xsi:nil="true"/>
+  </documentManagement>
+</p:properties>
+</file>
+
+<file path=customXml/item3.xml><?xml version="1.0" encoding="utf-8"?>
 <ct:contentTypeSchema xmlns:ct="http://schemas.microsoft.com/office/2006/metadata/contentType" xmlns:ma="http://schemas.microsoft.com/office/2006/metadata/properties/metaAttributes" ct:_="" ma:_="" ma:contentTypeName="Belge" ma:contentTypeID="0x010100A2D9663D32F195478084E660A9F44C9E" ma:contentTypeVersion="10" ma:contentTypeDescription="Yeni belge oluşturun." ma:contentTypeScope="" ma:versionID="6d98bf1c7ffb5fb69278a9c6338486c7">
   <xsd:schema xmlns:xsd="http://www.w3.org/2001/XMLSchema" xmlns:xs="http://www.w3.org/2001/XMLSchema" xmlns:p="http://schemas.microsoft.com/office/2006/metadata/properties" xmlns:ns2="7e9bba26-c7b2-4a27-a3ac-cd76b284cae0" xmlns:ns3="f76e5be2-97eb-4a1b-ab44-72f8057eaa93" targetNamespace="http://schemas.microsoft.com/office/2006/metadata/properties" ma:root="true" ma:fieldsID="508632a5764188408bb22ca1c81e76c3" ns2:_="" ns3:_="">
     <xsd:import namespace="7e9bba26-c7b2-4a27-a3ac-cd76b284cae0"/>
@@ -6836,17 +7196,6 @@
 </ct:contentTypeSchema>
 </file>
 
-<file path=customXml/item3.xml><?xml version="1.0" encoding="utf-8"?>
-<p:properties xmlns:p="http://schemas.microsoft.com/office/2006/metadata/properties" xmlns:xsi="http://www.w3.org/2001/XMLSchema-instance" xmlns:pc="http://schemas.microsoft.com/office/infopath/2007/PartnerControls">
-  <documentManagement>
-    <lcf76f155ced4ddcb4097134ff3c332f xmlns="7e9bba26-c7b2-4a27-a3ac-cd76b284cae0">
-      <Terms xmlns="http://schemas.microsoft.com/office/infopath/2007/PartnerControls"/>
-    </lcf76f155ced4ddcb4097134ff3c332f>
-    <TaxCatchAll xmlns="f76e5be2-97eb-4a1b-ab44-72f8057eaa93" xsi:nil="true"/>
-  </documentManagement>
-</p:properties>
-</file>
-
 <file path=customXml/itemProps1.xml><?xml version="1.0" encoding="utf-8"?>
 <ds:datastoreItem xmlns:ds="http://schemas.openxmlformats.org/officeDocument/2006/customXml" ds:itemID="{FD1AFEC2-01E4-469A-ACC5-AEBE441405A7}">
   <ds:schemaRefs>
@@ -6856,6 +7205,17 @@
 </file>
 
 <file path=customXml/itemProps2.xml><?xml version="1.0" encoding="utf-8"?>
+<ds:datastoreItem xmlns:ds="http://schemas.openxmlformats.org/officeDocument/2006/customXml" ds:itemID="{2E69D243-DBC8-4766-A43A-43C1845F72B7}">
+  <ds:schemaRefs>
+    <ds:schemaRef ds:uri="http://schemas.microsoft.com/office/2006/metadata/properties"/>
+    <ds:schemaRef ds:uri="http://schemas.microsoft.com/office/infopath/2007/PartnerControls"/>
+    <ds:schemaRef ds:uri="7e9bba26-c7b2-4a27-a3ac-cd76b284cae0"/>
+    <ds:schemaRef ds:uri="f76e5be2-97eb-4a1b-ab44-72f8057eaa93"/>
+  </ds:schemaRefs>
+</ds:datastoreItem>
+</file>
+
+<file path=customXml/itemProps3.xml><?xml version="1.0" encoding="utf-8"?>
 <ds:datastoreItem xmlns:ds="http://schemas.openxmlformats.org/officeDocument/2006/customXml" ds:itemID="{E313273B-2550-468A-8D3C-8EF0BB816CA6}">
   <ds:schemaRefs>
     <ds:schemaRef ds:uri="http://schemas.microsoft.com/office/2006/metadata/contentType"/>
@@ -6872,15 +7232,4 @@
     <ds:schemaRef ds:uri="http://schemas.microsoft.com/internal/obd"/>
   </ds:schemaRefs>
 </ds:datastoreItem>
-</file>
-
-<file path=customXml/itemProps3.xml><?xml version="1.0" encoding="utf-8"?>
-<ds:datastoreItem xmlns:ds="http://schemas.openxmlformats.org/officeDocument/2006/customXml" ds:itemID="{2E69D243-DBC8-4766-A43A-43C1845F72B7}">
-  <ds:schemaRefs>
-    <ds:schemaRef ds:uri="http://schemas.microsoft.com/office/2006/metadata/properties"/>
-    <ds:schemaRef ds:uri="http://schemas.microsoft.com/office/infopath/2007/PartnerControls"/>
-    <ds:schemaRef ds:uri="7e9bba26-c7b2-4a27-a3ac-cd76b284cae0"/>
-    <ds:schemaRef ds:uri="f76e5be2-97eb-4a1b-ab44-72f8057eaa93"/>
-  </ds:schemaRefs>
-</ds:datastoreItem>
 </file>
</xml_diff>